<commit_message>
세션 #01 마감 (2026-03-12, 09:30~10:51)
- NGINX Ingress EOL 대응: Traefik v3.x 채택, 전체 문서 반영
- Gateway 구축계획서 작성 (docs/05-deployment/02-gateway-architecture.md)
- GitHub Projects 보드 구성 (14 이슈, 15 라벨, 4 마일스톤)
- GitHub Projects 사용 매뉴얼 (docs/00-tools/20-github-projects.md)
- Claude Agent 팀 구성 (10 에이전트 + 2 오케스트레이션 커맨드)

Co-Authored-By: Claude Opus 4.6 <noreply@anthropic.com>
</commit_message>
<xml_diff>
--- a/docs/RummiArena_기획설계검토.pptx
+++ b/docs/RummiArena_기획설계검토.pptx
@@ -11383,7 +11383,7 @@
               <a:t>Docker Desktop K8s
 Helm 3
 ArgoCD
-NGINX Ingress</a:t>
+Traefik Ingress</a:t>
             </a:r>
           </a:p>
         </p:txBody>
@@ -25958,7 +25958,7 @@
                   <a:srgbClr val="CCCCCC"/>
                 </a:solidFill>
               </a:rPr>
-              <a:t>Ingress (NGINX)</a:t>
+              <a:t>Ingress (Traefik)</a:t>
             </a:r>
           </a:p>
         </p:txBody>
@@ -26018,9 +26018,8 @@
                   <a:srgbClr val="FFFFFF"/>
                 </a:solidFill>
               </a:rPr>
-              <a:t>NGINX
-Ingress
-Controller
+              <a:t>Traefik
+Proxy
 TLS 종단
 라우팅</a:t>
             </a:r>
@@ -32540,7 +32539,7 @@
                   <a:srgbClr val="CCCCCC"/>
                 </a:solidFill>
               </a:rPr>
-              <a:t>NGINX Ingress Controller  (TLS Termination, self-signed cert)</a:t>
+              <a:t>Traefik Proxy  (TLS Termination, self-signed cert)</a:t>
             </a:r>
           </a:p>
         </p:txBody>

</xml_diff>